<commit_message>
seragamkan isi: ambang ulasan, klaim transit, selisih janji, jabatan
- ambang ulasan buruk ditulis "telat 4-7 hari" di semua dokumen,
  sama dengan kelompok data dan judul grafik dasbor
- klaim lama transit dilunakkan: Parana transit lebih lama dari Sao Paulo
  tapi telatnya lebih rendah
- selisih janji "cenderung menyusut" (sempat naik Des 2017 & Jun 2018);
  perbaikan Jun tidak lagi diklaim terjadi meski janji makin ketat
- jabatan penyusun diseragamkan menjadi Analis Operasional
- laporan md/docx/pdf, presentasi, README, dan komentar SQL ikut diperbarui
</commit_message>
<xml_diff>
--- a/hasil/presentasi_diagnosis_keterlambatan.pptx
+++ b/hasil/presentasi_diagnosis_keterlambatan.pptx
@@ -5367,7 +5367,7 @@
                 <a:ea typeface="Calibri" pitchFamily="34" charset="-122"/>
                 <a:cs typeface="Calibri" pitchFamily="34" charset="-120"/>
               </a:rPr>
-              <a:t>Titik patah antara hari ke-3 dan ke-7. </a:t>
+              <a:t>Titik patah di kelompok telat 4–7 hari. </a:t>
             </a:r>
             <a:r>
               <a:rPr lang="en-US" sz="1100" dirty="0" err="1">
@@ -6344,7 +6344,7 @@
                 <a:ea typeface="Calibri" pitchFamily="34" charset="-122"/>
                 <a:cs typeface="Calibri" pitchFamily="34" charset="-120"/>
               </a:rPr>
-              <a:t>Kerusakan kepuasan melonjak di </a:t>
+              <a:t>Kerusakan kepuasan melonjak di telat 4–7 hari, jenuh setelah hari ke-8.</a:t>
             </a:r>
             <a:r>
               <a:rPr lang="en-US" sz="1000" dirty="0" err="1">
@@ -6355,7 +6355,7 @@
                 <a:ea typeface="Calibri" pitchFamily="34" charset="-122"/>
                 <a:cs typeface="Calibri" pitchFamily="34" charset="-120"/>
               </a:rPr>
-              <a:t>hari</a:t>
+              <a:t/>
             </a:r>
             <a:r>
               <a:rPr lang="en-US" sz="1000" dirty="0">
@@ -6366,7 +6366,7 @@
                 <a:ea typeface="Calibri" pitchFamily="34" charset="-122"/>
                 <a:cs typeface="Calibri" pitchFamily="34" charset="-120"/>
               </a:rPr>
-              <a:t> </a:t>
+              <a:t/>
             </a:r>
             <a:r>
               <a:rPr lang="en-US" sz="1000" dirty="0" err="1">
@@ -6377,7 +6377,7 @@
                 <a:ea typeface="Calibri" pitchFamily="34" charset="-122"/>
                 <a:cs typeface="Calibri" pitchFamily="34" charset="-120"/>
               </a:rPr>
-              <a:t>ke</a:t>
+              <a:t/>
             </a:r>
             <a:r>
               <a:rPr lang="en-US" sz="1000" dirty="0">
@@ -6388,7 +6388,7 @@
                 <a:ea typeface="Calibri" pitchFamily="34" charset="-122"/>
                 <a:cs typeface="Calibri" pitchFamily="34" charset="-120"/>
               </a:rPr>
-              <a:t> 3 - 7, jenuh setelah hari ke-8. Menarik </a:t>
+              <a:t> Menarik </a:t>
             </a:r>
             <a:r>
               <a:rPr lang="en-US" sz="1000" dirty="0" err="1">
@@ -9392,7 +9392,7 @@
                 <a:ea typeface="Calibri" pitchFamily="34" charset="-122"/>
                 <a:cs typeface="Calibri" pitchFamily="34" charset="-120"/>
               </a:rPr>
-              <a:t>Skor ulasan jatuh dari 4,30 ke 2,57 saat telat. Titik patah di </a:t>
+              <a:t>Skor ulasan jatuh dari 4,30 ke 2,57 saat telat. Titik patah di telat 4–7 hari.</a:t>
             </a:r>
             <a:r>
               <a:rPr lang="en-US" sz="1150" dirty="0" err="1">
@@ -9403,7 +9403,7 @@
                 <a:ea typeface="Calibri" pitchFamily="34" charset="-122"/>
                 <a:cs typeface="Calibri" pitchFamily="34" charset="-120"/>
               </a:rPr>
-              <a:t>hari</a:t>
+              <a:t/>
             </a:r>
             <a:r>
               <a:rPr lang="en-US" sz="1150" dirty="0">
@@ -9414,7 +9414,7 @@
                 <a:ea typeface="Calibri" pitchFamily="34" charset="-122"/>
                 <a:cs typeface="Calibri" pitchFamily="34" charset="-120"/>
               </a:rPr>
-              <a:t> ke-3-7. </a:t>
+              <a:t> </a:t>
             </a:r>
             <a:r>
               <a:rPr lang="en-US" sz="1150" dirty="0" err="1">

</xml_diff>